<commit_message>
Added FexPractice and GridPractice compnents
</commit_message>
<xml_diff>
--- a/slides/CSS Flex box & Flex gird.pptx
+++ b/slides/CSS Flex box & Flex gird.pptx
@@ -5,7 +5,7 @@
     <p:sldMasterId id="2147483650" r:id="rId1"/>
   </p:sldMasterIdLst>
   <p:notesMasterIdLst>
-    <p:notesMasterId r:id="rId14"/>
+    <p:notesMasterId r:id="rId15"/>
   </p:notesMasterIdLst>
   <p:sldIdLst>
     <p:sldId id="256" r:id="rId2"/>
@@ -20,6 +20,7 @@
     <p:sldId id="264" r:id="rId11"/>
     <p:sldId id="265" r:id="rId12"/>
     <p:sldId id="267" r:id="rId13"/>
+    <p:sldId id="268" r:id="rId14"/>
   </p:sldIdLst>
   <p:sldSz cx="12192000" cy="6858000"/>
   <p:notesSz cx="6858000" cy="9144000"/>
@@ -17431,14 +17432,16 @@
         </p:nvSpPr>
         <p:spPr/>
         <p:txBody>
-          <a:bodyPr/>
+          <a:bodyPr>
+            <a:normAutofit/>
+          </a:bodyPr>
           <a:lstStyle/>
           <a:p>
             <a:pPr marL="0" indent="0">
               <a:buNone/>
             </a:pPr>
             <a:r>
-              <a:rPr lang="en-US" dirty="0"/>
+              <a:rPr lang="en-US" sz="2400" dirty="0"/>
               <a:t>import styles from "./Boxes.module.css";</a:t>
             </a:r>
           </a:p>
@@ -17447,7 +17450,7 @@
               <a:buNone/>
             </a:pPr>
             <a:r>
-              <a:rPr lang="en-US" dirty="0"/>
+              <a:rPr lang="en-US" sz="2400" dirty="0"/>
               <a:t>export default function Boxes() {</a:t>
             </a:r>
           </a:p>
@@ -17459,7 +17462,7 @@
               <a:buNone/>
             </a:pPr>
             <a:r>
-              <a:rPr lang="en-US" dirty="0"/>
+              <a:rPr lang="en-US" sz="2400" dirty="0"/>
               <a:t>  return (</a:t>
             </a:r>
           </a:p>
@@ -17471,23 +17474,23 @@
               <a:buNone/>
             </a:pPr>
             <a:r>
-              <a:rPr lang="en-US" dirty="0"/>
+              <a:rPr lang="en-US" sz="2400" dirty="0"/>
               <a:t>    &lt;div </a:t>
             </a:r>
             <a:r>
-              <a:rPr lang="en-US" dirty="0" err="1"/>
+              <a:rPr lang="en-US" sz="2400" dirty="0" err="1"/>
               <a:t>className</a:t>
             </a:r>
             <a:r>
-              <a:rPr lang="en-US" dirty="0"/>
+              <a:rPr lang="en-US" sz="2400" dirty="0"/>
               <a:t>={</a:t>
             </a:r>
             <a:r>
-              <a:rPr lang="en-US" dirty="0" err="1"/>
+              <a:rPr lang="en-US" sz="2400" dirty="0" err="1"/>
               <a:t>styles.container</a:t>
             </a:r>
             <a:r>
-              <a:rPr lang="en-US" dirty="0"/>
+              <a:rPr lang="en-US" sz="2400" dirty="0"/>
               <a:t>}&gt;</a:t>
             </a:r>
           </a:p>
@@ -17499,23 +17502,23 @@
               <a:buNone/>
             </a:pPr>
             <a:r>
-              <a:rPr lang="en-US" dirty="0"/>
+              <a:rPr lang="en-US" sz="2400" dirty="0"/>
               <a:t>       &lt;div </a:t>
             </a:r>
             <a:r>
-              <a:rPr lang="en-US" dirty="0" err="1"/>
+              <a:rPr lang="en-US" sz="2400" dirty="0" err="1"/>
               <a:t>className</a:t>
             </a:r>
             <a:r>
-              <a:rPr lang="en-US" dirty="0"/>
+              <a:rPr lang="en-US" sz="2400" dirty="0"/>
               <a:t>={</a:t>
             </a:r>
             <a:r>
-              <a:rPr lang="en-US" dirty="0" err="1"/>
+              <a:rPr lang="en-US" sz="2400" dirty="0" err="1"/>
               <a:t>styles.item</a:t>
             </a:r>
             <a:r>
-              <a:rPr lang="en-US" dirty="0"/>
+              <a:rPr lang="en-US" sz="2400" dirty="0"/>
               <a:t>}&gt; Little Box&lt;/div&gt;</a:t>
             </a:r>
           </a:p>
@@ -17527,7 +17530,7 @@
               <a:buNone/>
             </a:pPr>
             <a:r>
-              <a:rPr lang="en-US" dirty="0"/>
+              <a:rPr lang="en-US" sz="2400" dirty="0"/>
               <a:t>    &lt;/div&gt;</a:t>
             </a:r>
           </a:p>
@@ -17539,7 +17542,7 @@
               <a:buNone/>
             </a:pPr>
             <a:r>
-              <a:rPr lang="en-US" dirty="0"/>
+              <a:rPr lang="en-US" sz="2400" dirty="0"/>
               <a:t>  )</a:t>
             </a:r>
           </a:p>
@@ -17551,7 +17554,7 @@
               <a:buNone/>
             </a:pPr>
             <a:r>
-              <a:rPr lang="en-US" dirty="0"/>
+              <a:rPr lang="en-US" sz="2400" dirty="0"/>
               <a:t>};</a:t>
             </a:r>
           </a:p>
@@ -17857,6 +17860,27 @@
           </a:bodyPr>
           <a:lstStyle/>
           <a:p>
+            <a:pPr marL="0" indent="0">
+              <a:spcBef>
+                <a:spcPts val="0"/>
+              </a:spcBef>
+              <a:buNone/>
+            </a:pPr>
+            <a:r>
+              <a:rPr lang="en-US" sz="2800" dirty="0"/>
+              <a:t>Typical flexbox layout</a:t>
+            </a:r>
+          </a:p>
+          <a:p>
+            <a:pPr marL="0" indent="0">
+              <a:spcBef>
+                <a:spcPts val="0"/>
+              </a:spcBef>
+              <a:buNone/>
+            </a:pPr>
+            <a:endParaRPr lang="en-US" sz="2800" dirty="0"/>
+          </a:p>
+          <a:p>
             <a:pPr>
               <a:spcBef>
                 <a:spcPts val="0"/>
@@ -17966,23 +17990,7 @@
                   <a:srgbClr val="00B050"/>
                 </a:solidFill>
               </a:rPr>
-              <a:t>  box-sizing: border-box;    /* width and </a:t>
-            </a:r>
-            <a:r>
-              <a:rPr lang="en-US" sz="2400">
-                <a:solidFill>
-                  <a:srgbClr val="00B050"/>
-                </a:solidFill>
-              </a:rPr>
-              <a:t>height include </a:t>
-            </a:r>
-            <a:r>
-              <a:rPr lang="en-US" sz="2400" dirty="0">
-                <a:solidFill>
-                  <a:srgbClr val="00B050"/>
-                </a:solidFill>
-              </a:rPr>
-              <a:t>padding and border*/ </a:t>
+              <a:t>  box-sizing: border-box;    /* width and height include padding and border*/ </a:t>
             </a:r>
           </a:p>
           <a:p>
@@ -18008,6 +18016,152 @@
     <p:extLst>
       <p:ext uri="{BB962C8B-B14F-4D97-AF65-F5344CB8AC3E}">
         <p14:creationId xmlns:p14="http://schemas.microsoft.com/office/powerpoint/2010/main" val="769394946"/>
+      </p:ext>
+    </p:extLst>
+  </p:cSld>
+  <p:clrMapOvr>
+    <a:masterClrMapping/>
+  </p:clrMapOvr>
+</p:sld>
+</file>
+
+<file path=ppt/slides/slide13.xml><?xml version="1.0" encoding="utf-8"?>
+<p:sld xmlns:a="http://schemas.openxmlformats.org/drawingml/2006/main" xmlns:r="http://schemas.openxmlformats.org/officeDocument/2006/relationships" xmlns:p="http://schemas.openxmlformats.org/presentationml/2006/main">
+  <p:cSld>
+    <p:spTree>
+      <p:nvGrpSpPr>
+        <p:cNvPr id="1" name=""/>
+        <p:cNvGrpSpPr/>
+        <p:nvPr/>
+      </p:nvGrpSpPr>
+      <p:grpSpPr>
+        <a:xfrm>
+          <a:off x="0" y="0"/>
+          <a:ext cx="0" cy="0"/>
+          <a:chOff x="0" y="0"/>
+          <a:chExt cx="0" cy="0"/>
+        </a:xfrm>
+      </p:grpSpPr>
+      <p:sp>
+        <p:nvSpPr>
+          <p:cNvPr id="2" name="Title 1">
+            <a:extLst>
+              <a:ext uri="{FF2B5EF4-FFF2-40B4-BE49-F238E27FC236}">
+                <a16:creationId xmlns:a16="http://schemas.microsoft.com/office/drawing/2014/main" id="{62C78E29-5D9E-4431-058D-7D03BCB442C7}"/>
+              </a:ext>
+            </a:extLst>
+          </p:cNvPr>
+          <p:cNvSpPr>
+            <a:spLocks noGrp="1"/>
+          </p:cNvSpPr>
+          <p:nvPr>
+            <p:ph type="title"/>
+          </p:nvPr>
+        </p:nvSpPr>
+        <p:spPr>
+          <a:xfrm>
+            <a:off x="429768" y="283464"/>
+            <a:ext cx="10652760" cy="1097280"/>
+          </a:xfrm>
+        </p:spPr>
+        <p:txBody>
+          <a:bodyPr/>
+          <a:lstStyle/>
+          <a:p>
+            <a:r>
+              <a:rPr lang="en-US" b="1" dirty="0"/>
+              <a:t>Flex Wrap property</a:t>
+            </a:r>
+            <a:br>
+              <a:rPr lang="en-US" b="1" dirty="0"/>
+            </a:br>
+            <a:endParaRPr lang="en-US" dirty="0"/>
+          </a:p>
+        </p:txBody>
+      </p:sp>
+      <p:sp>
+        <p:nvSpPr>
+          <p:cNvPr id="3" name="Content Placeholder 2">
+            <a:extLst>
+              <a:ext uri="{FF2B5EF4-FFF2-40B4-BE49-F238E27FC236}">
+                <a16:creationId xmlns:a16="http://schemas.microsoft.com/office/drawing/2014/main" id="{2925580E-BEA1-AFB3-73B0-46D703FCBA05}"/>
+              </a:ext>
+            </a:extLst>
+          </p:cNvPr>
+          <p:cNvSpPr>
+            <a:spLocks noGrp="1"/>
+          </p:cNvSpPr>
+          <p:nvPr>
+            <p:ph idx="1"/>
+          </p:nvPr>
+        </p:nvSpPr>
+        <p:spPr>
+          <a:xfrm>
+            <a:off x="429768" y="1101012"/>
+            <a:ext cx="10652760" cy="5180916"/>
+          </a:xfrm>
+        </p:spPr>
+        <p:txBody>
+          <a:bodyPr>
+            <a:normAutofit/>
+          </a:bodyPr>
+          <a:lstStyle/>
+          <a:p>
+            <a:r>
+              <a:rPr lang="en-US" sz="2400" dirty="0"/>
+              <a:t>The flex-wrap method allows contents to wrap around to the next available space instead of flowing off the screen.</a:t>
+            </a:r>
+          </a:p>
+          <a:p>
+            <a:r>
+              <a:rPr lang="en-US" sz="2400" dirty="0"/>
+              <a:t>Basic syntax              flex-wrap: wrap;</a:t>
+            </a:r>
+          </a:p>
+          <a:p>
+            <a:r>
+              <a:rPr lang="en-US" sz="2400" dirty="0"/>
+              <a:t>Properties:    </a:t>
+            </a:r>
+            <a:r>
+              <a:rPr lang="en-US" sz="2400" dirty="0" err="1"/>
+              <a:t>nowrap</a:t>
+            </a:r>
+            <a:r>
+              <a:rPr lang="en-US" sz="2400" dirty="0"/>
+              <a:t>   (default)</a:t>
+            </a:r>
+          </a:p>
+          <a:p>
+            <a:pPr marL="0" indent="0">
+              <a:buNone/>
+            </a:pPr>
+            <a:r>
+              <a:rPr lang="en-US" sz="2400" dirty="0"/>
+              <a:t>                          wrap</a:t>
+            </a:r>
+          </a:p>
+          <a:p>
+            <a:pPr marL="0" indent="0">
+              <a:buNone/>
+            </a:pPr>
+            <a:r>
+              <a:rPr lang="en-US" sz="2400" dirty="0"/>
+              <a:t>                          wrap-reverse </a:t>
+            </a:r>
+          </a:p>
+          <a:p>
+            <a:endParaRPr lang="en-US" sz="2400" dirty="0"/>
+          </a:p>
+          <a:p>
+            <a:endParaRPr lang="en-US" sz="2400" dirty="0"/>
+          </a:p>
+        </p:txBody>
+      </p:sp>
+    </p:spTree>
+    <p:extLst>
+      <p:ext uri="{BB962C8B-B14F-4D97-AF65-F5344CB8AC3E}">
+        <p14:creationId xmlns:p14="http://schemas.microsoft.com/office/powerpoint/2010/main" val="3020816254"/>
       </p:ext>
     </p:extLst>
   </p:cSld>
@@ -19020,7 +19174,12 @@
             <p:ph type="title"/>
           </p:nvPr>
         </p:nvSpPr>
-        <p:spPr/>
+        <p:spPr>
+          <a:xfrm>
+            <a:off x="429768" y="283464"/>
+            <a:ext cx="10652760" cy="630936"/>
+          </a:xfrm>
+        </p:spPr>
         <p:txBody>
           <a:bodyPr/>
           <a:lstStyle/>
@@ -19050,8 +19209,8 @@
         </p:nvSpPr>
         <p:spPr>
           <a:xfrm>
-            <a:off x="1932820" y="1252728"/>
-            <a:ext cx="7646656" cy="5096314"/>
+            <a:off x="1932820" y="914400"/>
+            <a:ext cx="7646656" cy="5411755"/>
           </a:xfrm>
         </p:spPr>
         <p:txBody>
@@ -19061,50 +19220,50 @@
           <a:lstStyle/>
           <a:p>
             <a:r>
-              <a:rPr lang="en-US" dirty="0"/>
+              <a:rPr lang="en-US" sz="2000" dirty="0"/>
               <a:t>Grid is </a:t>
             </a:r>
             <a:r>
-              <a:rPr lang="en-US" b="1" dirty="0"/>
+              <a:rPr lang="en-US" sz="2000" b="1" dirty="0"/>
               <a:t>two-dimensional</a:t>
             </a:r>
             <a:r>
-              <a:rPr lang="en-US" dirty="0"/>
+              <a:rPr lang="en-US" sz="2000" dirty="0"/>
               <a:t> (rows and columns).</a:t>
             </a:r>
           </a:p>
           <a:p>
             <a:r>
-              <a:rPr lang="en-US" dirty="0"/>
+              <a:rPr lang="en-US" sz="2000" dirty="0"/>
               <a:t>grid-template-columns defines column tracks.</a:t>
             </a:r>
           </a:p>
           <a:p>
             <a:r>
-              <a:rPr lang="en-US" dirty="0"/>
+              <a:rPr lang="en-US" sz="2000" dirty="0"/>
               <a:t>grid-template-rows defines row tracks.</a:t>
             </a:r>
           </a:p>
           <a:p>
             <a:r>
-              <a:rPr lang="en-US" dirty="0"/>
+              <a:rPr lang="en-US" sz="2000" dirty="0"/>
               <a:t>gap controls spacing between tracks.</a:t>
             </a:r>
           </a:p>
           <a:p>
             <a:r>
-              <a:rPr lang="en-US" dirty="0"/>
+              <a:rPr lang="en-US" sz="2000" dirty="0"/>
               <a:t>grid-column and grid-row control placement.</a:t>
             </a:r>
           </a:p>
           <a:p>
             <a:r>
-              <a:rPr lang="en-US" dirty="0"/>
+              <a:rPr lang="en-US" sz="2000" dirty="0"/>
               <a:t>grid-template-areas allows named layout regions like this:</a:t>
             </a:r>
           </a:p>
           <a:p>
-            <a:endParaRPr lang="en-US" dirty="0"/>
+            <a:endParaRPr lang="en-US" sz="2000" dirty="0"/>
           </a:p>
           <a:p>
             <a:pPr marL="0" indent="0">
@@ -19684,22 +19843,24 @@
           </a:xfrm>
         </p:spPr>
         <p:txBody>
-          <a:bodyPr/>
+          <a:bodyPr>
+            <a:normAutofit/>
+          </a:bodyPr>
           <a:lstStyle/>
           <a:p>
             <a:pPr marL="0" indent="0">
               <a:buNone/>
             </a:pPr>
             <a:r>
-              <a:rPr lang="en-US" dirty="0"/>
+              <a:rPr lang="en-US" sz="2400" dirty="0"/>
               <a:t>Moving boxes around helps to </a:t>
             </a:r>
             <a:r>
-              <a:rPr lang="en-US" dirty="0" err="1"/>
+              <a:rPr lang="en-US" sz="2400" dirty="0" err="1"/>
               <a:t>inderstand</a:t>
             </a:r>
             <a:r>
-              <a:rPr lang="en-US" dirty="0"/>
+              <a:rPr lang="en-US" sz="2400" dirty="0"/>
               <a:t> how layouts work with flexbox and grid. Think of a big box that holds little boxes that holds stuff. First you tell the big box (.container or .wrapper) how to arrange the little boxes (.item or .header).Then tell how to arrange the stuff that’s in the little boxes.</a:t>
             </a:r>
           </a:p>
@@ -19708,7 +19869,7 @@
               <a:buNone/>
             </a:pPr>
             <a:r>
-              <a:rPr lang="en-US" dirty="0"/>
+              <a:rPr lang="en-US" sz="2400" dirty="0"/>
               <a:t>If it makes sense to use a grid that’s what you should use. If you’re using grid and fighting with rows and columns you should switch to flex, its that simple. </a:t>
             </a:r>
           </a:p>
@@ -19803,7 +19964,7 @@
         </p:spPr>
         <p:txBody>
           <a:bodyPr>
-            <a:normAutofit/>
+            <a:normAutofit fontScale="85000" lnSpcReduction="10000"/>
           </a:bodyPr>
           <a:lstStyle/>
           <a:p>
@@ -19811,16 +19972,8 @@
               <a:buNone/>
             </a:pPr>
             <a:r>
-              <a:rPr lang="en-US" dirty="0"/>
-              <a:t>From now on when you see &lt;div </a:t>
-            </a:r>
-            <a:r>
-              <a:rPr lang="en-US" dirty="0" err="1"/>
-              <a:t>className</a:t>
-            </a:r>
-            <a:r>
-              <a:rPr lang="en-US" dirty="0"/>
-              <a:t>&gt; hello &lt;/div&gt; think box.</a:t>
+              <a:rPr lang="en-US" sz="2000" dirty="0"/>
+              <a:t>Big box = container,  Little box = item</a:t>
             </a:r>
           </a:p>
           <a:p>
@@ -19828,8 +19981,16 @@
               <a:buNone/>
             </a:pPr>
             <a:r>
-              <a:rPr lang="en-US" dirty="0"/>
-              <a:t>Big box = container,  Little box = item</a:t>
+              <a:rPr lang="en-US" sz="2000" dirty="0"/>
+              <a:t>Thes two </a:t>
+            </a:r>
+            <a:r>
+              <a:rPr lang="en-US" sz="2000" dirty="0" err="1"/>
+              <a:t>css</a:t>
+            </a:r>
+            <a:r>
+              <a:rPr lang="en-US" sz="2000" dirty="0"/>
+              <a:t> classes will give you a grey box 500px wide with a blue box perfectly aligned in the center</a:t>
             </a:r>
           </a:p>
           <a:p>
@@ -19837,24 +19998,7 @@
               <a:buNone/>
             </a:pPr>
             <a:r>
-              <a:rPr lang="en-US" sz="1400" dirty="0"/>
-              <a:t>Thes two </a:t>
-            </a:r>
-            <a:r>
-              <a:rPr lang="en-US" sz="1400" dirty="0" err="1"/>
-              <a:t>css</a:t>
-            </a:r>
-            <a:r>
-              <a:rPr lang="en-US" sz="1400" dirty="0"/>
-              <a:t> classes will give you a grey box 500px wide with a blue box perfectly aligned in the center</a:t>
-            </a:r>
-          </a:p>
-          <a:p>
-            <a:pPr marL="0" indent="0">
-              <a:buNone/>
-            </a:pPr>
-            <a:r>
-              <a:rPr lang="en-US" sz="1400" dirty="0"/>
+              <a:rPr lang="en-US" sz="2000" dirty="0"/>
               <a:t>.container {</a:t>
             </a:r>
           </a:p>
@@ -19866,7 +20010,7 @@
               <a:buNone/>
             </a:pPr>
             <a:r>
-              <a:rPr lang="en-US" sz="1400" dirty="0"/>
+              <a:rPr lang="en-US" sz="2000" dirty="0"/>
               <a:t>  display: flex;</a:t>
             </a:r>
           </a:p>
@@ -19878,7 +20022,7 @@
               <a:buNone/>
             </a:pPr>
             <a:r>
-              <a:rPr lang="en-US" sz="1400" dirty="0"/>
+              <a:rPr lang="en-US" sz="2000" dirty="0"/>
               <a:t>  flex-direction: column;</a:t>
             </a:r>
           </a:p>
@@ -19890,7 +20034,7 @@
               <a:buNone/>
             </a:pPr>
             <a:r>
-              <a:rPr lang="en-US" sz="1400" dirty="0"/>
+              <a:rPr lang="en-US" sz="2000" dirty="0"/>
               <a:t>  justify-content: space-between;</a:t>
             </a:r>
           </a:p>
@@ -19902,7 +20046,7 @@
               <a:buNone/>
             </a:pPr>
             <a:r>
-              <a:rPr lang="en-US" sz="1400" dirty="0"/>
+              <a:rPr lang="en-US" sz="2000" dirty="0"/>
               <a:t>  align-items: center;</a:t>
             </a:r>
           </a:p>
@@ -19914,7 +20058,7 @@
               <a:buNone/>
             </a:pPr>
             <a:r>
-              <a:rPr lang="en-US" sz="1400" dirty="0"/>
+              <a:rPr lang="en-US" sz="2000" dirty="0"/>
               <a:t>  box-sizing: border-box;</a:t>
             </a:r>
           </a:p>
@@ -19926,7 +20070,7 @@
               <a:buNone/>
             </a:pPr>
             <a:r>
-              <a:rPr lang="en-US" sz="1400" dirty="0"/>
+              <a:rPr lang="en-US" sz="2000" dirty="0"/>
               <a:t>  height: 500;</a:t>
             </a:r>
           </a:p>
@@ -19938,7 +20082,7 @@
               <a:buNone/>
             </a:pPr>
             <a:r>
-              <a:rPr lang="en-US" sz="1400" dirty="0"/>
+              <a:rPr lang="en-US" sz="2000" dirty="0"/>
               <a:t>  width: 500px;</a:t>
             </a:r>
           </a:p>
@@ -19950,7 +20094,7 @@
               <a:buNone/>
             </a:pPr>
             <a:r>
-              <a:rPr lang="en-US" sz="1400" dirty="0"/>
+              <a:rPr lang="en-US" sz="2000" dirty="0"/>
               <a:t>  border: 1px solid #aaaaaa;</a:t>
             </a:r>
           </a:p>
@@ -19962,7 +20106,7 @@
               <a:buNone/>
             </a:pPr>
             <a:r>
-              <a:rPr lang="en-US" sz="1400" dirty="0"/>
+              <a:rPr lang="en-US" sz="2000" dirty="0"/>
               <a:t>  background-color: #454545;</a:t>
             </a:r>
           </a:p>
@@ -19974,7 +20118,7 @@
               <a:buNone/>
             </a:pPr>
             <a:r>
-              <a:rPr lang="en-US" sz="1400" dirty="0"/>
+              <a:rPr lang="en-US" sz="2000" dirty="0"/>
               <a:t>}</a:t>
             </a:r>
           </a:p>
@@ -19986,7 +20130,7 @@
               <a:buNone/>
             </a:pPr>
             <a:r>
-              <a:rPr lang="en-US" sz="1400" dirty="0"/>
+              <a:rPr lang="en-US" sz="2000" dirty="0"/>
               <a:t>.item {</a:t>
             </a:r>
           </a:p>
@@ -19998,7 +20142,7 @@
               <a:buNone/>
             </a:pPr>
             <a:r>
-              <a:rPr lang="en-US" sz="1400" dirty="0"/>
+              <a:rPr lang="en-US" sz="2000" dirty="0"/>
               <a:t>  height: 100px;</a:t>
             </a:r>
           </a:p>
@@ -20010,7 +20154,7 @@
               <a:buNone/>
             </a:pPr>
             <a:r>
-              <a:rPr lang="en-US" sz="1400" dirty="0"/>
+              <a:rPr lang="en-US" sz="2000" dirty="0"/>
               <a:t>  width: 100px;</a:t>
             </a:r>
           </a:p>
@@ -20022,7 +20166,7 @@
               <a:buNone/>
             </a:pPr>
             <a:r>
-              <a:rPr lang="en-US" sz="1400" dirty="0"/>
+              <a:rPr lang="en-US" sz="2000" dirty="0"/>
               <a:t>  border: 2px solid blue;</a:t>
             </a:r>
           </a:p>
@@ -20034,15 +20178,15 @@
               <a:buNone/>
             </a:pPr>
             <a:r>
-              <a:rPr lang="en-US" sz="1400" dirty="0"/>
+              <a:rPr lang="en-US" sz="2000" dirty="0"/>
               <a:t>  background-color: </a:t>
             </a:r>
             <a:r>
-              <a:rPr lang="en-US" sz="1400" dirty="0" err="1"/>
+              <a:rPr lang="en-US" sz="2000" dirty="0" err="1"/>
               <a:t>lightblue</a:t>
             </a:r>
             <a:r>
-              <a:rPr lang="en-US" sz="1400" dirty="0"/>
+              <a:rPr lang="en-US" sz="2000" dirty="0"/>
               <a:t>;</a:t>
             </a:r>
           </a:p>
@@ -20054,7 +20198,7 @@
               <a:buNone/>
             </a:pPr>
             <a:r>
-              <a:rPr lang="en-US" sz="1400" dirty="0"/>
+              <a:rPr lang="en-US" sz="2000" dirty="0"/>
               <a:t>}</a:t>
             </a:r>
           </a:p>

</xml_diff>